<commit_message>
Live Trading and few rectifications on UI/UX done
</commit_message>
<xml_diff>
--- a/Documentation/PPT_Synopsis.pptx
+++ b/Documentation/PPT_Synopsis.pptx
@@ -298,7 +298,7 @@
           <a:p>
             <a:fld id="{B0AC3275-9D44-403D-A9EB-A3A69884D368}" type="datetimeFigureOut">
               <a:rPr lang="en-US" smtClean="0"/>
-              <a:t>2/9/2026</a:t>
+              <a:t>3/14/2026</a:t>
             </a:fld>
             <a:endParaRPr lang="en-US"/>
           </a:p>
@@ -476,7 +476,7 @@
             <a:fld id="{640C79F9-0E80-4B59-BFBF-922194FB6FE7}" type="datetimeFigureOut">
               <a:rPr lang="en-US" smtClean="0"/>
               <a:pPr/>
-              <a:t>2/9/2026</a:t>
+              <a:t>3/14/2026</a:t>
             </a:fld>
             <a:endParaRPr lang="en-US"/>
           </a:p>
@@ -799,7 +799,7 @@
             <a:fld id="{AD5D2152-08A9-004F-BE32-52A9C6BDFCAD}" type="datetimeFigureOut">
               <a:rPr lang="en-US" smtClean="0"/>
               <a:pPr/>
-              <a:t>2/9/2026</a:t>
+              <a:t>3/14/2026</a:t>
             </a:fld>
             <a:endParaRPr lang="en-US"/>
           </a:p>
@@ -928,7 +928,7 @@
             <a:fld id="{AD5D2152-08A9-004F-BE32-52A9C6BDFCAD}" type="datetimeFigureOut">
               <a:rPr lang="en-US" smtClean="0"/>
               <a:pPr/>
-              <a:t>2/9/2026</a:t>
+              <a:t>3/14/2026</a:t>
             </a:fld>
             <a:endParaRPr lang="en-US"/>
           </a:p>
@@ -1091,7 +1091,7 @@
             <a:fld id="{AD5D2152-08A9-004F-BE32-52A9C6BDFCAD}" type="datetimeFigureOut">
               <a:rPr lang="en-US" smtClean="0"/>
               <a:pPr/>
-              <a:t>2/9/2026</a:t>
+              <a:t>3/14/2026</a:t>
             </a:fld>
             <a:endParaRPr lang="en-US"/>
           </a:p>
@@ -1475,7 +1475,7 @@
             <a:fld id="{AD5D2152-08A9-004F-BE32-52A9C6BDFCAD}" type="datetimeFigureOut">
               <a:rPr lang="en-US" smtClean="0"/>
               <a:pPr/>
-              <a:t>2/9/2026</a:t>
+              <a:t>3/14/2026</a:t>
             </a:fld>
             <a:endParaRPr lang="en-US"/>
           </a:p>
@@ -1598,7 +1598,7 @@
             <a:fld id="{AD5D2152-08A9-004F-BE32-52A9C6BDFCAD}" type="datetimeFigureOut">
               <a:rPr lang="en-US" smtClean="0"/>
               <a:pPr/>
-              <a:t>2/9/2026</a:t>
+              <a:t>3/14/2026</a:t>
             </a:fld>
             <a:endParaRPr lang="en-US"/>
           </a:p>
@@ -1820,7 +1820,7 @@
             <a:fld id="{AD5D2152-08A9-004F-BE32-52A9C6BDFCAD}" type="datetimeFigureOut">
               <a:rPr lang="en-US" smtClean="0"/>
               <a:pPr/>
-              <a:t>2/9/2026</a:t>
+              <a:t>3/14/2026</a:t>
             </a:fld>
             <a:endParaRPr lang="en-US"/>
           </a:p>
@@ -3611,7 +3611,7 @@
         <p:spPr>
           <a:xfrm>
             <a:off x="2069210" y="1811506"/>
-            <a:ext cx="8254366" cy="2369880"/>
+            <a:ext cx="8254366" cy="3293209"/>
           </a:xfrm>
           <a:prstGeom prst="rect">
             <a:avLst/>
@@ -3658,6 +3658,28 @@
                 <a:cs typeface="Times New Roman" panose="02020603050405020304" pitchFamily="18" charset="0"/>
               </a:rPr>
               <a:t> is a virtual stock trading platform designed to help beginners learn stock trading without financial risk. It provides real-time market visualization, virtual trading, portfolio analytics, and structured learning modules.</a:t>
+            </a:r>
+          </a:p>
+          <a:p>
+            <a:endParaRPr lang="en-US" sz="2000" dirty="0">
+              <a:latin typeface="Times New Roman" panose="02020603050405020304" pitchFamily="18" charset="0"/>
+              <a:cs typeface="Times New Roman" panose="02020603050405020304" pitchFamily="18" charset="0"/>
+            </a:endParaRPr>
+          </a:p>
+          <a:p>
+            <a:endParaRPr lang="en-US" sz="2000" dirty="0">
+              <a:latin typeface="Times New Roman" panose="02020603050405020304" pitchFamily="18" charset="0"/>
+              <a:cs typeface="Times New Roman" panose="02020603050405020304" pitchFamily="18" charset="0"/>
+            </a:endParaRPr>
+          </a:p>
+          <a:p>
+            <a:pPr algn="r"/>
+            <a:r>
+              <a:rPr lang="en-US" sz="1800" b="1" i="1" dirty="0">
+                <a:latin typeface="Times New Roman" panose="02020603050405020304" pitchFamily="18" charset="0"/>
+                <a:cs typeface="Times New Roman" panose="02020603050405020304" pitchFamily="18" charset="0"/>
+              </a:rPr>
+              <a:t>Mentor: Dr Keshav Sinha</a:t>
             </a:r>
           </a:p>
           <a:p>

</xml_diff>